<commit_message>
qa gate: read absolute artifact paths (is_final placeholder check now actually fires) +3 tests; master template: title boxes 1.05->1.50in, icons capped 2in, timeline pins match phases, deck-own properties
</commit_message>
<xml_diff>
--- a/plugins/ice-b2b-sales/skills/b2b-slide-designer/assets/masters/iCE-Propose_Master.pptx
+++ b/plugins/ice-b2b-sales/skills/b2b-slide-designer/assets/masters/iCE-Propose_Master.pptx
@@ -1082,7 +1082,7 @@
         </p:nvSpPr>
         <p:spPr>
           <a:xfrm>
-            <a:off x="548640" y="548640"/>
+            <a:off x="548640" y="754380"/>
             <a:ext cx="685800" cy="685800"/>
           </a:xfrm>
           <a:prstGeom prst="rect">
@@ -1125,18 +1125,19 @@
         <p:spPr>
           <a:xfrm>
             <a:off x="1417320" y="411480"/>
-            <a:ext cx="9171286" cy="960120"/>
-          </a:xfrm>
-          <a:prstGeom prst="rect">
-            <a:avLst/>
-          </a:prstGeom>
-        </p:spPr>
-        <p:txBody>
-          <a:bodyPr wrap="square" lIns="0" tIns="0" rIns="0" bIns="0" rtlCol="0" anchor="ctr">
-            <a:normAutofit/>
-          </a:bodyPr>
+            <a:ext cx="9171286" cy="1371600"/>
+          </a:xfrm>
+          <a:prstGeom prst="rect">
+            <a:avLst/>
+          </a:prstGeom>
+        </p:spPr>
+        <p:txBody>
+          <a:bodyPr wrap="square" lIns="0" tIns="0" rIns="0" bIns="0" rtlCol="0" anchor="ctr"/>
           <a:lstStyle>
             <a:lvl1pPr marL="0" indent="0" algn="l">
+              <a:lnSpc>
+                <a:spcPct val="100000"/>
+              </a:lnSpc>
               <a:buNone/>
               <a:defRPr sz="2600" b="1">
                 <a:solidFill>
@@ -1148,6 +1149,9 @@
               </a:defRPr>
             </a:lvl1pPr>
             <a:lvl2pPr marL="0" indent="0" algn="l">
+              <a:lnSpc>
+                <a:spcPct val="100000"/>
+              </a:lnSpc>
               <a:buNone/>
               <a:defRPr sz="2600">
                 <a:solidFill>
@@ -1175,7 +1179,7 @@
         </p:nvCxnSpPr>
         <p:spPr>
           <a:xfrm>
-            <a:off x="548640" y="1508760"/>
+            <a:off x="548640" y="1920240"/>
             <a:ext cx="2011680" cy="0"/>
           </a:xfrm>
           <a:prstGeom prst="line">
@@ -1216,8 +1220,8 @@
         </p:nvSpPr>
         <p:spPr>
           <a:xfrm>
-            <a:off x="548640" y="1783080"/>
-            <a:ext cx="6400800" cy="4160520"/>
+            <a:off x="548640" y="2148840"/>
+            <a:ext cx="6400800" cy="3794760"/>
           </a:xfrm>
           <a:prstGeom prst="rect">
             <a:avLst/>
@@ -1285,8 +1289,8 @@
         </p:nvSpPr>
         <p:spPr>
           <a:xfrm>
-            <a:off x="7315200" y="1783080"/>
-            <a:ext cx="4327855" cy="4160520"/>
+            <a:off x="7315200" y="2148840"/>
+            <a:ext cx="4327855" cy="3794760"/>
           </a:xfrm>
           <a:prstGeom prst="rect">
             <a:avLst/>
@@ -1448,7 +1452,7 @@
         </p:nvSpPr>
         <p:spPr>
           <a:xfrm>
-            <a:off x="548640" y="548640"/>
+            <a:off x="548640" y="754380"/>
             <a:ext cx="685800" cy="685800"/>
           </a:xfrm>
           <a:prstGeom prst="rect">
@@ -1491,18 +1495,19 @@
         <p:spPr>
           <a:xfrm>
             <a:off x="1417320" y="411480"/>
-            <a:ext cx="9171286" cy="960120"/>
-          </a:xfrm>
-          <a:prstGeom prst="rect">
-            <a:avLst/>
-          </a:prstGeom>
-        </p:spPr>
-        <p:txBody>
-          <a:bodyPr wrap="square" lIns="0" tIns="0" rIns="0" bIns="0" rtlCol="0" anchor="ctr">
-            <a:normAutofit/>
-          </a:bodyPr>
+            <a:ext cx="9171286" cy="1371600"/>
+          </a:xfrm>
+          <a:prstGeom prst="rect">
+            <a:avLst/>
+          </a:prstGeom>
+        </p:spPr>
+        <p:txBody>
+          <a:bodyPr wrap="square" lIns="0" tIns="0" rIns="0" bIns="0" rtlCol="0" anchor="ctr"/>
           <a:lstStyle>
             <a:lvl1pPr marL="0" indent="0" algn="l">
+              <a:lnSpc>
+                <a:spcPct val="100000"/>
+              </a:lnSpc>
               <a:buNone/>
               <a:defRPr sz="2600" b="1">
                 <a:solidFill>
@@ -1514,6 +1519,9 @@
               </a:defRPr>
             </a:lvl1pPr>
             <a:lvl2pPr marL="0" indent="0" algn="l">
+              <a:lnSpc>
+                <a:spcPct val="100000"/>
+              </a:lnSpc>
               <a:buNone/>
               <a:defRPr sz="2600">
                 <a:solidFill>
@@ -1541,7 +1549,7 @@
         </p:nvCxnSpPr>
         <p:spPr>
           <a:xfrm>
-            <a:off x="548640" y="1508760"/>
+            <a:off x="548640" y="1920240"/>
             <a:ext cx="2011680" cy="0"/>
           </a:xfrm>
           <a:prstGeom prst="line">
@@ -1582,7 +1590,7 @@
         </p:nvSpPr>
         <p:spPr>
           <a:xfrm>
-            <a:off x="548640" y="1783080"/>
+            <a:off x="548640" y="2148840"/>
             <a:ext cx="457200" cy="457200"/>
           </a:xfrm>
           <a:prstGeom prst="rect">
@@ -1624,7 +1632,7 @@
         </p:nvSpPr>
         <p:spPr>
           <a:xfrm>
-            <a:off x="1143000" y="1737360"/>
+            <a:off x="1143000" y="2103120"/>
             <a:ext cx="4701388" cy="548640"/>
           </a:xfrm>
           <a:prstGeom prst="rect">
@@ -1677,8 +1685,8 @@
         </p:nvSpPr>
         <p:spPr>
           <a:xfrm>
-            <a:off x="548640" y="2423160"/>
-            <a:ext cx="5295748" cy="3520440"/>
+            <a:off x="548640" y="2788920"/>
+            <a:ext cx="5295748" cy="3154680"/>
           </a:xfrm>
           <a:prstGeom prst="rect">
             <a:avLst/>
@@ -1742,8 +1750,8 @@
         </p:nvCxnSpPr>
         <p:spPr>
           <a:xfrm>
-            <a:off x="6095848" y="1783080"/>
-            <a:ext cx="0" cy="4160520"/>
+            <a:off x="6095848" y="2148840"/>
+            <a:ext cx="0" cy="3794760"/>
           </a:xfrm>
           <a:prstGeom prst="line">
             <a:avLst/>
@@ -1770,7 +1778,7 @@
         </p:nvSpPr>
         <p:spPr>
           <a:xfrm>
-            <a:off x="6347308" y="1783080"/>
+            <a:off x="6347308" y="2148840"/>
             <a:ext cx="457200" cy="457200"/>
           </a:xfrm>
           <a:prstGeom prst="rect">
@@ -1812,7 +1820,7 @@
         </p:nvSpPr>
         <p:spPr>
           <a:xfrm>
-            <a:off x="6941668" y="1737360"/>
+            <a:off x="6941668" y="2103120"/>
             <a:ext cx="4701388" cy="548640"/>
           </a:xfrm>
           <a:prstGeom prst="rect">
@@ -1865,8 +1873,8 @@
         </p:nvSpPr>
         <p:spPr>
           <a:xfrm>
-            <a:off x="6347308" y="2423160"/>
-            <a:ext cx="5295748" cy="3520440"/>
+            <a:off x="6347308" y="2788920"/>
+            <a:ext cx="5295748" cy="3154680"/>
           </a:xfrm>
           <a:prstGeom prst="rect">
             <a:avLst/>
@@ -2055,7 +2063,7 @@
         </p:nvSpPr>
         <p:spPr>
           <a:xfrm>
-            <a:off x="548640" y="548640"/>
+            <a:off x="548640" y="754380"/>
             <a:ext cx="685800" cy="685800"/>
           </a:xfrm>
           <a:prstGeom prst="rect">
@@ -2098,18 +2106,19 @@
         <p:spPr>
           <a:xfrm>
             <a:off x="1417320" y="411480"/>
-            <a:ext cx="9171286" cy="960120"/>
-          </a:xfrm>
-          <a:prstGeom prst="rect">
-            <a:avLst/>
-          </a:prstGeom>
-        </p:spPr>
-        <p:txBody>
-          <a:bodyPr wrap="square" lIns="0" tIns="0" rIns="0" bIns="0" rtlCol="0" anchor="ctr">
-            <a:normAutofit/>
-          </a:bodyPr>
+            <a:ext cx="9171286" cy="1371600"/>
+          </a:xfrm>
+          <a:prstGeom prst="rect">
+            <a:avLst/>
+          </a:prstGeom>
+        </p:spPr>
+        <p:txBody>
+          <a:bodyPr wrap="square" lIns="0" tIns="0" rIns="0" bIns="0" rtlCol="0" anchor="ctr"/>
           <a:lstStyle>
             <a:lvl1pPr marL="0" indent="0" algn="l">
+              <a:lnSpc>
+                <a:spcPct val="100000"/>
+              </a:lnSpc>
               <a:buNone/>
               <a:defRPr sz="2600" b="1">
                 <a:solidFill>
@@ -2121,6 +2130,9 @@
               </a:defRPr>
             </a:lvl1pPr>
             <a:lvl2pPr marL="0" indent="0" algn="l">
+              <a:lnSpc>
+                <a:spcPct val="100000"/>
+              </a:lnSpc>
               <a:buNone/>
               <a:defRPr sz="2600">
                 <a:solidFill>
@@ -2148,7 +2160,7 @@
         </p:nvCxnSpPr>
         <p:spPr>
           <a:xfrm>
-            <a:off x="548640" y="1508760"/>
+            <a:off x="548640" y="1920240"/>
             <a:ext cx="2011680" cy="0"/>
           </a:xfrm>
           <a:prstGeom prst="line">
@@ -2185,8 +2197,8 @@
         </p:nvSpPr>
         <p:spPr>
           <a:xfrm>
-            <a:off x="548640" y="1783080"/>
-            <a:ext cx="3515258" cy="4160520"/>
+            <a:off x="548640" y="2148840"/>
+            <a:ext cx="3515258" cy="3794760"/>
           </a:xfrm>
           <a:prstGeom prst="roundRect">
             <a:avLst/>
@@ -2209,7 +2221,7 @@
         </p:nvSpPr>
         <p:spPr>
           <a:xfrm>
-            <a:off x="566928" y="1783080"/>
+            <a:off x="566928" y="2148840"/>
             <a:ext cx="3478682" cy="82296"/>
           </a:xfrm>
           <a:prstGeom prst="rect">
@@ -2243,7 +2255,7 @@
         </p:nvSpPr>
         <p:spPr>
           <a:xfrm>
-            <a:off x="822960" y="2103120"/>
+            <a:off x="822960" y="2468880"/>
             <a:ext cx="640080" cy="640080"/>
           </a:xfrm>
           <a:prstGeom prst="rect">
@@ -2285,7 +2297,7 @@
         </p:nvSpPr>
         <p:spPr>
           <a:xfrm>
-            <a:off x="822960" y="2880360"/>
+            <a:off x="822960" y="3246120"/>
             <a:ext cx="2966618" cy="548640"/>
           </a:xfrm>
           <a:prstGeom prst="rect">
@@ -2338,8 +2350,8 @@
         </p:nvSpPr>
         <p:spPr>
           <a:xfrm>
-            <a:off x="822960" y="3520440"/>
-            <a:ext cx="2966618" cy="2148840"/>
+            <a:off x="822960" y="3886200"/>
+            <a:ext cx="2966618" cy="1783080"/>
           </a:xfrm>
           <a:prstGeom prst="rect">
             <a:avLst/>
@@ -2403,8 +2415,8 @@
         </p:nvSpPr>
         <p:spPr>
           <a:xfrm>
-            <a:off x="4338218" y="1783080"/>
-            <a:ext cx="3515258" cy="4160520"/>
+            <a:off x="4338218" y="2148840"/>
+            <a:ext cx="3515258" cy="3794760"/>
           </a:xfrm>
           <a:prstGeom prst="roundRect">
             <a:avLst/>
@@ -2427,7 +2439,7 @@
         </p:nvSpPr>
         <p:spPr>
           <a:xfrm>
-            <a:off x="4356506" y="1783080"/>
+            <a:off x="4356506" y="2148840"/>
             <a:ext cx="3478682" cy="82296"/>
           </a:xfrm>
           <a:prstGeom prst="rect">
@@ -2461,7 +2473,7 @@
         </p:nvSpPr>
         <p:spPr>
           <a:xfrm>
-            <a:off x="4612538" y="2103120"/>
+            <a:off x="4612538" y="2468880"/>
             <a:ext cx="640080" cy="640080"/>
           </a:xfrm>
           <a:prstGeom prst="rect">
@@ -2503,7 +2515,7 @@
         </p:nvSpPr>
         <p:spPr>
           <a:xfrm>
-            <a:off x="4612538" y="2880360"/>
+            <a:off x="4612538" y="3246120"/>
             <a:ext cx="2966618" cy="548640"/>
           </a:xfrm>
           <a:prstGeom prst="rect">
@@ -2556,8 +2568,8 @@
         </p:nvSpPr>
         <p:spPr>
           <a:xfrm>
-            <a:off x="4612538" y="3520440"/>
-            <a:ext cx="2966618" cy="2148840"/>
+            <a:off x="4612538" y="3886200"/>
+            <a:ext cx="2966618" cy="1783080"/>
           </a:xfrm>
           <a:prstGeom prst="rect">
             <a:avLst/>
@@ -2621,8 +2633,8 @@
         </p:nvSpPr>
         <p:spPr>
           <a:xfrm>
-            <a:off x="8127797" y="1783080"/>
-            <a:ext cx="3515258" cy="4160520"/>
+            <a:off x="8127797" y="2148840"/>
+            <a:ext cx="3515258" cy="3794760"/>
           </a:xfrm>
           <a:prstGeom prst="roundRect">
             <a:avLst/>
@@ -2645,7 +2657,7 @@
         </p:nvSpPr>
         <p:spPr>
           <a:xfrm>
-            <a:off x="8146085" y="1783080"/>
+            <a:off x="8146085" y="2148840"/>
             <a:ext cx="3478682" cy="82296"/>
           </a:xfrm>
           <a:prstGeom prst="rect">
@@ -2679,7 +2691,7 @@
         </p:nvSpPr>
         <p:spPr>
           <a:xfrm>
-            <a:off x="8402117" y="2103120"/>
+            <a:off x="8402117" y="2468880"/>
             <a:ext cx="640080" cy="640080"/>
           </a:xfrm>
           <a:prstGeom prst="rect">
@@ -2721,7 +2733,7 @@
         </p:nvSpPr>
         <p:spPr>
           <a:xfrm>
-            <a:off x="8402117" y="2880360"/>
+            <a:off x="8402117" y="3246120"/>
             <a:ext cx="2966618" cy="548640"/>
           </a:xfrm>
           <a:prstGeom prst="rect">
@@ -2774,8 +2786,8 @@
         </p:nvSpPr>
         <p:spPr>
           <a:xfrm>
-            <a:off x="8402117" y="3520440"/>
-            <a:ext cx="2966618" cy="2148840"/>
+            <a:off x="8402117" y="3886200"/>
+            <a:ext cx="2966618" cy="1783080"/>
           </a:xfrm>
           <a:prstGeom prst="rect">
             <a:avLst/>
@@ -2964,7 +2976,7 @@
         </p:nvSpPr>
         <p:spPr>
           <a:xfrm>
-            <a:off x="548640" y="548640"/>
+            <a:off x="548640" y="754380"/>
             <a:ext cx="685800" cy="685800"/>
           </a:xfrm>
           <a:prstGeom prst="rect">
@@ -3007,18 +3019,19 @@
         <p:spPr>
           <a:xfrm>
             <a:off x="1417320" y="411480"/>
-            <a:ext cx="9171286" cy="960120"/>
-          </a:xfrm>
-          <a:prstGeom prst="rect">
-            <a:avLst/>
-          </a:prstGeom>
-        </p:spPr>
-        <p:txBody>
-          <a:bodyPr wrap="square" lIns="0" tIns="0" rIns="0" bIns="0" rtlCol="0" anchor="ctr">
-            <a:normAutofit/>
-          </a:bodyPr>
+            <a:ext cx="9171286" cy="1371600"/>
+          </a:xfrm>
+          <a:prstGeom prst="rect">
+            <a:avLst/>
+          </a:prstGeom>
+        </p:spPr>
+        <p:txBody>
+          <a:bodyPr wrap="square" lIns="0" tIns="0" rIns="0" bIns="0" rtlCol="0" anchor="ctr"/>
           <a:lstStyle>
             <a:lvl1pPr marL="0" indent="0" algn="l">
+              <a:lnSpc>
+                <a:spcPct val="100000"/>
+              </a:lnSpc>
               <a:buNone/>
               <a:defRPr sz="2600" b="1">
                 <a:solidFill>
@@ -3030,6 +3043,9 @@
               </a:defRPr>
             </a:lvl1pPr>
             <a:lvl2pPr marL="0" indent="0" algn="l">
+              <a:lnSpc>
+                <a:spcPct val="100000"/>
+              </a:lnSpc>
               <a:buNone/>
               <a:defRPr sz="2600">
                 <a:solidFill>
@@ -3057,7 +3073,7 @@
         </p:nvCxnSpPr>
         <p:spPr>
           <a:xfrm>
-            <a:off x="548640" y="1508760"/>
+            <a:off x="548640" y="1920240"/>
             <a:ext cx="2011680" cy="0"/>
           </a:xfrm>
           <a:prstGeom prst="line">
@@ -3098,8 +3114,8 @@
         </p:nvSpPr>
         <p:spPr>
           <a:xfrm>
-            <a:off x="548640" y="1783080"/>
-            <a:ext cx="11094415" cy="3566160"/>
+            <a:off x="548640" y="2148840"/>
+            <a:ext cx="11094415" cy="3246120"/>
           </a:xfrm>
         </p:spPr>
         <p:txBody>
@@ -3311,7 +3327,7 @@
         </p:nvSpPr>
         <p:spPr>
           <a:xfrm>
-            <a:off x="548640" y="548640"/>
+            <a:off x="548640" y="754380"/>
             <a:ext cx="685800" cy="685800"/>
           </a:xfrm>
           <a:prstGeom prst="rect">
@@ -3354,18 +3370,19 @@
         <p:spPr>
           <a:xfrm>
             <a:off x="1417320" y="411480"/>
-            <a:ext cx="9171286" cy="960120"/>
-          </a:xfrm>
-          <a:prstGeom prst="rect">
-            <a:avLst/>
-          </a:prstGeom>
-        </p:spPr>
-        <p:txBody>
-          <a:bodyPr wrap="square" lIns="0" tIns="0" rIns="0" bIns="0" rtlCol="0" anchor="ctr">
-            <a:normAutofit/>
-          </a:bodyPr>
+            <a:ext cx="9171286" cy="1371600"/>
+          </a:xfrm>
+          <a:prstGeom prst="rect">
+            <a:avLst/>
+          </a:prstGeom>
+        </p:spPr>
+        <p:txBody>
+          <a:bodyPr wrap="square" lIns="0" tIns="0" rIns="0" bIns="0" rtlCol="0" anchor="ctr"/>
           <a:lstStyle>
             <a:lvl1pPr marL="0" indent="0" algn="l">
+              <a:lnSpc>
+                <a:spcPct val="100000"/>
+              </a:lnSpc>
               <a:buNone/>
               <a:defRPr sz="2600" b="1">
                 <a:solidFill>
@@ -3377,6 +3394,9 @@
               </a:defRPr>
             </a:lvl1pPr>
             <a:lvl2pPr marL="0" indent="0" algn="l">
+              <a:lnSpc>
+                <a:spcPct val="100000"/>
+              </a:lnSpc>
               <a:buNone/>
               <a:defRPr sz="2600">
                 <a:solidFill>
@@ -3404,7 +3424,7 @@
         </p:nvCxnSpPr>
         <p:spPr>
           <a:xfrm>
-            <a:off x="548640" y="1508760"/>
+            <a:off x="548640" y="1920240"/>
             <a:ext cx="2011680" cy="0"/>
           </a:xfrm>
           <a:prstGeom prst="line">
@@ -3433,107 +3453,42 @@
           </a:ln>
         </p:spPr>
       </p:cxnSp>
-      <p:cxnSp>
-        <p:nvCxnSpPr>
-          <p:cNvPr id="5" name="Timeline Track"/>
-          <p:cNvCxnSpPr/>
-          <p:nvPr/>
-        </p:nvCxnSpPr>
-        <p:spPr>
-          <a:xfrm>
-            <a:off x="822960" y="3383280"/>
-            <a:ext cx="10545775" cy="0"/>
-          </a:xfrm>
-          <a:prstGeom prst="line">
-            <a:avLst/>
-          </a:prstGeom>
-          <a:ln w="63500" cap="rnd">
-            <a:gradFill rotWithShape="1">
-              <a:gsLst>
-                <a:gs pos="0">
+      <p:sp>
+        <p:nvSpPr>
+          <p:cNvPr id="5" name="Phase 1 Label Placeholder"/>
+          <p:cNvSpPr>
+            <a:spLocks noGrp="1"/>
+          </p:cNvSpPr>
+          <p:nvPr>
+            <p:ph type="body" idx="1"/>
+          </p:nvPr>
+        </p:nvSpPr>
+        <p:spPr>
+          <a:xfrm>
+            <a:off x="640080" y="2468880"/>
+            <a:ext cx="2590724" cy="731520"/>
+          </a:xfrm>
+          <a:prstGeom prst="rect">
+            <a:avLst/>
+          </a:prstGeom>
+        </p:spPr>
+        <p:txBody>
+          <a:bodyPr wrap="square" lIns="0" tIns="0" rIns="0" bIns="0" rtlCol="0" anchor="b"/>
+          <a:lstStyle>
+            <a:lvl1pPr marL="0" indent="0" algn="ctr">
+              <a:buNone/>
+              <a:defRPr sz="1600" b="1">
+                <a:solidFill>
                   <a:srgbClr val="1E66A4"/>
-                </a:gs>
-                <a:gs pos="100000">
-                  <a:srgbClr val="41A8B5"/>
-                </a:gs>
-              </a:gsLst>
-              <a:lin ang="0" scaled="0"/>
-            </a:gradFill>
-            <a:round/>
-          </a:ln>
-        </p:spPr>
-      </p:cxnSp>
-      <p:sp>
-        <p:nvSpPr>
-          <p:cNvPr id="6" name="Milestone 1"/>
-          <p:cNvSpPr/>
-          <p:nvPr/>
-        </p:nvSpPr>
-        <p:spPr>
-          <a:xfrm>
-            <a:off x="1697698" y="3145536"/>
-            <a:ext cx="475488" cy="475488"/>
-          </a:xfrm>
-          <a:prstGeom prst="ellipse">
-            <a:avLst/>
-          </a:prstGeom>
-          <a:solidFill>
-            <a:srgbClr val="15375C"/>
-          </a:solidFill>
-          <a:ln w="19050">
-            <a:solidFill>
-              <a:srgbClr val="FFFFFF"/>
-            </a:solidFill>
-          </a:ln>
-        </p:spPr>
-        <p:txBody>
-          <a:bodyPr wrap="square" lIns="0" tIns="0" rIns="0" bIns="0" anchor="ctr" rtlCol="0"/>
-          <a:lstStyle/>
-          <a:p>
-            <a:pPr algn="ctr">
-              <a:spcAft>
-                <a:spcPts val="0"/>
-              </a:spcAft>
-            </a:pPr>
-            <a:r>
-              <a:rPr lang="th-TH" sz="1400" b="1" dirty="0">
-                <a:solidFill>
-                  <a:srgbClr val="FFFFFF"/>
-                </a:solidFill>
-                <a:latin typeface="IBM Plex Sans Thai Looped"/>
-                <a:ea typeface="IBM Plex Sans Thai Looped"/>
-                <a:cs typeface="IBM Plex Sans Thai Looped"/>
-              </a:rPr>
-              <a:t>1</a:t>
-            </a:r>
-          </a:p>
-        </p:txBody>
-      </p:sp>
-      <p:sp>
-        <p:nvSpPr>
-          <p:cNvPr id="7" name="Phase 1 Label Placeholder"/>
-          <p:cNvSpPr>
-            <a:spLocks noGrp="1"/>
-          </p:cNvSpPr>
-          <p:nvPr>
-            <p:ph type="body" idx="1"/>
-          </p:nvPr>
-        </p:nvSpPr>
-        <p:spPr>
-          <a:xfrm>
-            <a:off x="640080" y="2331720"/>
-            <a:ext cx="2590724" cy="731520"/>
-          </a:xfrm>
-          <a:prstGeom prst="rect">
-            <a:avLst/>
-          </a:prstGeom>
-        </p:spPr>
-        <p:txBody>
-          <a:bodyPr wrap="square" lIns="0" tIns="0" rIns="0" bIns="0" rtlCol="0" anchor="b"/>
-          <a:lstStyle>
-            <a:lvl1pPr marL="0" indent="0" algn="ctr">
-              <a:buNone/>
-              <a:defRPr sz="1600" b="1">
+                </a:solidFill>
+                <a:latin typeface="IBM Plex Sans Thai Looped"/>
+                <a:ea typeface="IBM Plex Sans Thai Looped"/>
+                <a:cs typeface="IBM Plex Sans Thai Looped"/>
+              </a:defRPr>
+            </a:lvl1pPr>
+            <a:lvl2pPr marL="0" indent="0" algn="ctr">
+              <a:buNone/>
+              <a:defRPr sz="1600">
                 <a:solidFill>
                   <a:srgbClr val="1E66A4"/>
                 </a:solidFill>
@@ -3541,17 +3496,6 @@
                 <a:ea typeface="IBM Plex Sans Thai Looped"/>
                 <a:cs typeface="IBM Plex Sans Thai Looped"/>
               </a:defRPr>
-            </a:lvl1pPr>
-            <a:lvl2pPr marL="0" indent="0" algn="ctr">
-              <a:buNone/>
-              <a:defRPr sz="1600">
-                <a:solidFill>
-                  <a:srgbClr val="1E66A4"/>
-                </a:solidFill>
-                <a:latin typeface="IBM Plex Sans Thai Looped"/>
-                <a:ea typeface="IBM Plex Sans Thai Looped"/>
-                <a:cs typeface="IBM Plex Sans Thai Looped"/>
-              </a:defRPr>
             </a:lvl2pPr>
           </a:lstStyle>
           <a:p>
@@ -3564,7 +3508,7 @@
       </p:sp>
       <p:sp>
         <p:nvSpPr>
-          <p:cNvPr id="8" name="Phase 1 Detail Placeholder"/>
+          <p:cNvPr id="6" name="Phase 1 Detail Placeholder"/>
           <p:cNvSpPr>
             <a:spLocks noGrp="1"/>
           </p:cNvSpPr>
@@ -3574,8 +3518,8 @@
         </p:nvSpPr>
         <p:spPr>
           <a:xfrm>
-            <a:off x="640080" y="3749040"/>
-            <a:ext cx="2590724" cy="2194560"/>
+            <a:off x="640080" y="3886200"/>
+            <a:ext cx="2590724" cy="2057400"/>
           </a:xfrm>
           <a:prstGeom prst="rect">
             <a:avLst/>
@@ -3619,53 +3563,7 @@
       </p:sp>
       <p:sp>
         <p:nvSpPr>
-          <p:cNvPr id="9" name="Milestone 2"/>
-          <p:cNvSpPr/>
-          <p:nvPr/>
-        </p:nvSpPr>
-        <p:spPr>
-          <a:xfrm>
-            <a:off x="4471302" y="3145536"/>
-            <a:ext cx="475488" cy="475488"/>
-          </a:xfrm>
-          <a:prstGeom prst="ellipse">
-            <a:avLst/>
-          </a:prstGeom>
-          <a:solidFill>
-            <a:srgbClr val="1E66A4"/>
-          </a:solidFill>
-          <a:ln w="19050">
-            <a:solidFill>
-              <a:srgbClr val="FFFFFF"/>
-            </a:solidFill>
-          </a:ln>
-        </p:spPr>
-        <p:txBody>
-          <a:bodyPr wrap="square" lIns="0" tIns="0" rIns="0" bIns="0" anchor="ctr" rtlCol="0"/>
-          <a:lstStyle/>
-          <a:p>
-            <a:pPr algn="ctr">
-              <a:spcAft>
-                <a:spcPts val="0"/>
-              </a:spcAft>
-            </a:pPr>
-            <a:r>
-              <a:rPr lang="th-TH" sz="1400" b="1" dirty="0">
-                <a:solidFill>
-                  <a:srgbClr val="FFFFFF"/>
-                </a:solidFill>
-                <a:latin typeface="IBM Plex Sans Thai Looped"/>
-                <a:ea typeface="IBM Plex Sans Thai Looped"/>
-                <a:cs typeface="IBM Plex Sans Thai Looped"/>
-              </a:rPr>
-              <a:t>2</a:t>
-            </a:r>
-          </a:p>
-        </p:txBody>
-      </p:sp>
-      <p:sp>
-        <p:nvSpPr>
-          <p:cNvPr id="10" name="Phase 2 Label Placeholder"/>
+          <p:cNvPr id="7" name="Phase 2 Label Placeholder"/>
           <p:cNvSpPr>
             <a:spLocks noGrp="1"/>
           </p:cNvSpPr>
@@ -3675,7 +3573,7 @@
         </p:nvSpPr>
         <p:spPr>
           <a:xfrm>
-            <a:off x="3413684" y="2331720"/>
+            <a:off x="3413684" y="2468880"/>
             <a:ext cx="2590724" cy="731520"/>
           </a:xfrm>
           <a:prstGeom prst="rect">
@@ -3718,7 +3616,7 @@
       </p:sp>
       <p:sp>
         <p:nvSpPr>
-          <p:cNvPr id="11" name="Phase 2 Detail Placeholder"/>
+          <p:cNvPr id="8" name="Phase 2 Detail Placeholder"/>
           <p:cNvSpPr>
             <a:spLocks noGrp="1"/>
           </p:cNvSpPr>
@@ -3728,8 +3626,8 @@
         </p:nvSpPr>
         <p:spPr>
           <a:xfrm>
-            <a:off x="3413684" y="3749040"/>
-            <a:ext cx="2590724" cy="2194560"/>
+            <a:off x="3413684" y="3886200"/>
+            <a:ext cx="2590724" cy="2057400"/>
           </a:xfrm>
           <a:prstGeom prst="rect">
             <a:avLst/>
@@ -3773,53 +3671,7 @@
       </p:sp>
       <p:sp>
         <p:nvSpPr>
-          <p:cNvPr id="12" name="Milestone 3"/>
-          <p:cNvSpPr/>
-          <p:nvPr/>
-        </p:nvSpPr>
-        <p:spPr>
-          <a:xfrm>
-            <a:off x="7244906" y="3145536"/>
-            <a:ext cx="475488" cy="475488"/>
-          </a:xfrm>
-          <a:prstGeom prst="ellipse">
-            <a:avLst/>
-          </a:prstGeom>
-          <a:solidFill>
-            <a:srgbClr val="2E8FB8"/>
-          </a:solidFill>
-          <a:ln w="19050">
-            <a:solidFill>
-              <a:srgbClr val="FFFFFF"/>
-            </a:solidFill>
-          </a:ln>
-        </p:spPr>
-        <p:txBody>
-          <a:bodyPr wrap="square" lIns="0" tIns="0" rIns="0" bIns="0" anchor="ctr" rtlCol="0"/>
-          <a:lstStyle/>
-          <a:p>
-            <a:pPr algn="ctr">
-              <a:spcAft>
-                <a:spcPts val="0"/>
-              </a:spcAft>
-            </a:pPr>
-            <a:r>
-              <a:rPr lang="th-TH" sz="1400" b="1" dirty="0">
-                <a:solidFill>
-                  <a:srgbClr val="FFFFFF"/>
-                </a:solidFill>
-                <a:latin typeface="IBM Plex Sans Thai Looped"/>
-                <a:ea typeface="IBM Plex Sans Thai Looped"/>
-                <a:cs typeface="IBM Plex Sans Thai Looped"/>
-              </a:rPr>
-              <a:t>3</a:t>
-            </a:r>
-          </a:p>
-        </p:txBody>
-      </p:sp>
-      <p:sp>
-        <p:nvSpPr>
-          <p:cNvPr id="13" name="Phase 3 Label Placeholder"/>
+          <p:cNvPr id="9" name="Phase 3 Label Placeholder"/>
           <p:cNvSpPr>
             <a:spLocks noGrp="1"/>
           </p:cNvSpPr>
@@ -3829,7 +3681,7 @@
         </p:nvSpPr>
         <p:spPr>
           <a:xfrm>
-            <a:off x="6187288" y="2331720"/>
+            <a:off x="6187288" y="2468880"/>
             <a:ext cx="2590724" cy="731520"/>
           </a:xfrm>
           <a:prstGeom prst="rect">
@@ -3872,7 +3724,7 @@
       </p:sp>
       <p:sp>
         <p:nvSpPr>
-          <p:cNvPr id="14" name="Phase 3 Detail Placeholder"/>
+          <p:cNvPr id="10" name="Phase 3 Detail Placeholder"/>
           <p:cNvSpPr>
             <a:spLocks noGrp="1"/>
           </p:cNvSpPr>
@@ -3882,8 +3734,8 @@
         </p:nvSpPr>
         <p:spPr>
           <a:xfrm>
-            <a:off x="6187288" y="3749040"/>
-            <a:ext cx="2590724" cy="2194560"/>
+            <a:off x="6187288" y="3886200"/>
+            <a:ext cx="2590724" cy="2057400"/>
           </a:xfrm>
           <a:prstGeom prst="rect">
             <a:avLst/>
@@ -3927,53 +3779,7 @@
       </p:sp>
       <p:sp>
         <p:nvSpPr>
-          <p:cNvPr id="15" name="Milestone 4"/>
-          <p:cNvSpPr/>
-          <p:nvPr/>
-        </p:nvSpPr>
-        <p:spPr>
-          <a:xfrm>
-            <a:off x="10018509" y="3145536"/>
-            <a:ext cx="475488" cy="475488"/>
-          </a:xfrm>
-          <a:prstGeom prst="ellipse">
-            <a:avLst/>
-          </a:prstGeom>
-          <a:solidFill>
-            <a:srgbClr val="41A8B5"/>
-          </a:solidFill>
-          <a:ln w="19050">
-            <a:solidFill>
-              <a:srgbClr val="FFFFFF"/>
-            </a:solidFill>
-          </a:ln>
-        </p:spPr>
-        <p:txBody>
-          <a:bodyPr wrap="square" lIns="0" tIns="0" rIns="0" bIns="0" anchor="ctr" rtlCol="0"/>
-          <a:lstStyle/>
-          <a:p>
-            <a:pPr algn="ctr">
-              <a:spcAft>
-                <a:spcPts val="0"/>
-              </a:spcAft>
-            </a:pPr>
-            <a:r>
-              <a:rPr lang="th-TH" sz="1400" b="1" dirty="0">
-                <a:solidFill>
-                  <a:srgbClr val="FFFFFF"/>
-                </a:solidFill>
-                <a:latin typeface="IBM Plex Sans Thai Looped"/>
-                <a:ea typeface="IBM Plex Sans Thai Looped"/>
-                <a:cs typeface="IBM Plex Sans Thai Looped"/>
-              </a:rPr>
-              <a:t>4</a:t>
-            </a:r>
-          </a:p>
-        </p:txBody>
-      </p:sp>
-      <p:sp>
-        <p:nvSpPr>
-          <p:cNvPr id="16" name="Phase 4 Label Placeholder"/>
+          <p:cNvPr id="11" name="Phase 4 Label Placeholder"/>
           <p:cNvSpPr>
             <a:spLocks noGrp="1"/>
           </p:cNvSpPr>
@@ -3983,7 +3789,7 @@
         </p:nvSpPr>
         <p:spPr>
           <a:xfrm>
-            <a:off x="8960891" y="2331720"/>
+            <a:off x="8960891" y="2468880"/>
             <a:ext cx="2590724" cy="731520"/>
           </a:xfrm>
           <a:prstGeom prst="rect">
@@ -4026,7 +3832,7 @@
       </p:sp>
       <p:sp>
         <p:nvSpPr>
-          <p:cNvPr id="17" name="Phase 4 Detail Placeholder"/>
+          <p:cNvPr id="12" name="Phase 4 Detail Placeholder"/>
           <p:cNvSpPr>
             <a:spLocks noGrp="1"/>
           </p:cNvSpPr>
@@ -4036,8 +3842,8 @@
         </p:nvSpPr>
         <p:spPr>
           <a:xfrm>
-            <a:off x="8960891" y="3749040"/>
-            <a:ext cx="2590724" cy="2194560"/>
+            <a:off x="8960891" y="3886200"/>
+            <a:ext cx="2590724" cy="2057400"/>
           </a:xfrm>
           <a:prstGeom prst="rect">
             <a:avLst/>
@@ -4081,7 +3887,7 @@
       </p:sp>
       <p:sp>
         <p:nvSpPr>
-          <p:cNvPr id="18" name="Footer Placeholder"/>
+          <p:cNvPr id="13" name="Footer Placeholder"/>
           <p:cNvSpPr>
             <a:spLocks noGrp="1"/>
           </p:cNvSpPr>
@@ -4134,7 +3940,7 @@
       </p:sp>
       <p:sp>
         <p:nvSpPr>
-          <p:cNvPr id="19" name="Slide Number Placeholder"/>
+          <p:cNvPr id="14" name="Slide Number Placeholder"/>
           <p:cNvSpPr>
             <a:spLocks noGrp="1"/>
           </p:cNvSpPr>
@@ -4598,7 +4404,7 @@
         </p:nvSpPr>
         <p:spPr>
           <a:xfrm>
-            <a:off x="548640" y="548640"/>
+            <a:off x="548640" y="754380"/>
             <a:ext cx="685800" cy="685800"/>
           </a:xfrm>
           <a:prstGeom prst="rect">
@@ -4641,18 +4447,19 @@
         <p:spPr>
           <a:xfrm>
             <a:off x="1417320" y="411480"/>
-            <a:ext cx="9171286" cy="960120"/>
-          </a:xfrm>
-          <a:prstGeom prst="rect">
-            <a:avLst/>
-          </a:prstGeom>
-        </p:spPr>
-        <p:txBody>
-          <a:bodyPr wrap="square" lIns="0" tIns="0" rIns="0" bIns="0" rtlCol="0" anchor="ctr">
-            <a:normAutofit/>
-          </a:bodyPr>
+            <a:ext cx="9171286" cy="1371600"/>
+          </a:xfrm>
+          <a:prstGeom prst="rect">
+            <a:avLst/>
+          </a:prstGeom>
+        </p:spPr>
+        <p:txBody>
+          <a:bodyPr wrap="square" lIns="0" tIns="0" rIns="0" bIns="0" rtlCol="0" anchor="ctr"/>
           <a:lstStyle>
             <a:lvl1pPr marL="0" indent="0" algn="l">
+              <a:lnSpc>
+                <a:spcPct val="100000"/>
+              </a:lnSpc>
               <a:buNone/>
               <a:defRPr sz="2600" b="1">
                 <a:solidFill>
@@ -4664,6 +4471,9 @@
               </a:defRPr>
             </a:lvl1pPr>
             <a:lvl2pPr marL="0" indent="0" algn="l">
+              <a:lnSpc>
+                <a:spcPct val="100000"/>
+              </a:lnSpc>
               <a:buNone/>
               <a:defRPr sz="2600">
                 <a:solidFill>
@@ -4691,7 +4501,7 @@
         </p:nvCxnSpPr>
         <p:spPr>
           <a:xfrm>
-            <a:off x="548640" y="1508760"/>
+            <a:off x="548640" y="1920240"/>
             <a:ext cx="2011680" cy="0"/>
           </a:xfrm>
           <a:prstGeom prst="line">
@@ -4732,8 +4542,8 @@
         </p:nvSpPr>
         <p:spPr>
           <a:xfrm>
-            <a:off x="548640" y="1783080"/>
-            <a:ext cx="11094415" cy="4160520"/>
+            <a:off x="548640" y="2148840"/>
+            <a:ext cx="11094415" cy="3794760"/>
           </a:xfrm>
           <a:prstGeom prst="rect">
             <a:avLst/>
@@ -4990,18 +4800,19 @@
         <p:spPr>
           <a:xfrm>
             <a:off x="1417320" y="411480"/>
-            <a:ext cx="9171286" cy="960120"/>
-          </a:xfrm>
-          <a:prstGeom prst="rect">
-            <a:avLst/>
-          </a:prstGeom>
-        </p:spPr>
-        <p:txBody>
-          <a:bodyPr wrap="square" lIns="0" tIns="0" rIns="0" bIns="0" rtlCol="0" anchor="ctr">
-            <a:normAutofit/>
-          </a:bodyPr>
+            <a:ext cx="9171286" cy="1371600"/>
+          </a:xfrm>
+          <a:prstGeom prst="rect">
+            <a:avLst/>
+          </a:prstGeom>
+        </p:spPr>
+        <p:txBody>
+          <a:bodyPr wrap="square" lIns="0" tIns="0" rIns="0" bIns="0" rtlCol="0" anchor="ctr"/>
           <a:lstStyle>
             <a:lvl1pPr marL="0" indent="0" algn="l">
+              <a:lnSpc>
+                <a:spcPct val="100000"/>
+              </a:lnSpc>
               <a:buNone/>
               <a:defRPr sz="2600" b="1">
                 <a:solidFill>
@@ -5013,6 +4824,9 @@
               </a:defRPr>
             </a:lvl1pPr>
             <a:lvl2pPr marL="0" indent="0" algn="l">
+              <a:lnSpc>
+                <a:spcPct val="100000"/>
+              </a:lnSpc>
               <a:buNone/>
               <a:defRPr sz="2600">
                 <a:solidFill>
@@ -5044,8 +4858,8 @@
         </p:nvSpPr>
         <p:spPr>
           <a:xfrm>
-            <a:off x="548640" y="1783080"/>
-            <a:ext cx="11094415" cy="4160520"/>
+            <a:off x="548640" y="2148840"/>
+            <a:ext cx="11094415" cy="3794760"/>
           </a:xfrm>
           <a:prstGeom prst="rect">
             <a:avLst/>
@@ -5215,6 +5029,9 @@
   <p:txStyles>
     <p:titleStyle>
       <a:lvl1pPr algn="l">
+        <a:lnSpc>
+          <a:spcPct val="100000"/>
+        </a:lnSpc>
         <a:defRPr sz="2600" b="1">
           <a:solidFill>
             <a:srgbClr val="15375C"/>

</xml_diff>

<commit_message>
round-3 findings fixed at source: master gains title line-spacing on cover/divider/closing (Thai tone marks collided) and drops the stale screen4x3 attribute; validate_pptx_structure now checks declared slide size and app.xml (a D4 rule that had no checker); build_pptx writes extended file properties; thai_wordbreak flags compounds split across lines (ทีม|บัญชี) which segmentation alone treats as legal
</commit_message>
<xml_diff>
--- a/plugins/ice-b2b-sales/skills/b2b-slide-designer/assets/masters/iCE-Propose_Master.pptx
+++ b/plugins/ice-b2b-sales/skills/b2b-slide-designer/assets/masters/iCE-Propose_Master.pptx
@@ -5,7 +5,7 @@
     <p:sldMasterId id="2147483648" r:id="rId1"/>
   </p:sldMasterIdLst>
   <p:sldIdLst/>
-  <p:sldSz cx="12192000" cy="6858000" type="screen4x3"/>
+  <p:sldSz cx="12192000" cy="6858000"/>
   <p:notesSz cx="6858000" cy="9144000"/>
   <p:defaultTextStyle>
     <a:defPPr>
@@ -291,6 +291,9 @@
           </a:bodyPr>
           <a:lstStyle>
             <a:lvl1pPr marL="0" indent="0" algn="l">
+              <a:lnSpc>
+                <a:spcPct val="100000"/>
+              </a:lnSpc>
               <a:buNone/>
               <a:defRPr sz="4000" b="1">
                 <a:solidFill>
@@ -302,6 +305,9 @@
               </a:defRPr>
             </a:lvl1pPr>
             <a:lvl2pPr marL="0" indent="0" algn="l">
+              <a:lnSpc>
+                <a:spcPct val="100000"/>
+              </a:lnSpc>
               <a:buNone/>
               <a:defRPr sz="4000">
                 <a:solidFill>
@@ -829,6 +835,9 @@
           </a:bodyPr>
           <a:lstStyle>
             <a:lvl1pPr marL="0" indent="0" algn="l">
+              <a:lnSpc>
+                <a:spcPct val="100000"/>
+              </a:lnSpc>
               <a:buNone/>
               <a:defRPr sz="3600" b="1">
                 <a:solidFill>
@@ -840,6 +849,9 @@
               </a:defRPr>
             </a:lvl1pPr>
             <a:lvl2pPr marL="0" indent="0" algn="l">
+              <a:lnSpc>
+                <a:spcPct val="100000"/>
+              </a:lnSpc>
               <a:buNone/>
               <a:defRPr sz="3600">
                 <a:solidFill>
@@ -4122,6 +4134,9 @@
           </a:bodyPr>
           <a:lstStyle>
             <a:lvl1pPr marL="0" indent="0" algn="l">
+              <a:lnSpc>
+                <a:spcPct val="100000"/>
+              </a:lnSpc>
               <a:buNone/>
               <a:defRPr sz="4000" b="1">
                 <a:solidFill>
@@ -4133,6 +4148,9 @@
               </a:defRPr>
             </a:lvl1pPr>
             <a:lvl2pPr marL="0" indent="0" algn="l">
+              <a:lnSpc>
+                <a:spcPct val="100000"/>
+              </a:lnSpc>
               <a:buNone/>
               <a:defRPr sz="4000">
                 <a:solidFill>

</xml_diff>